<commit_message>
Update tutor visual logic and presentation docs
</commit_message>
<xml_diff>
--- a/intro_stats_study_app_presentation_cleaned_v2.pptx
+++ b/intro_stats_study_app_presentation_cleaned_v2.pptx
@@ -469,7 +469,7 @@
 </file>
 
 <file path=ppt/notesSlides/notesSlide1.xml><?xml version="1.0" encoding="utf-8"?>
-<p:notes xmlns:a="http://schemas.openxmlformats.org/drawingml/2006/main" xmlns:r="http://schemas.openxmlformats.org/officeDocument/2006/relationships" xmlns:p="http://schemas.openxmlformats.org/presentationml/2006/main">
+<p:notes xmlns:a="http://schemas.openxmlformats.org/drawingml/2006/main" xmlns:ns2="http://schemas.microsoft.com/office/powerpoint/2010/main" xmlns:p="http://schemas.openxmlformats.org/presentationml/2006/main">
   <p:cSld>
     <p:spTree>
       <p:nvGrpSpPr>
@@ -514,7 +514,21 @@
           <a:p>
             <a:r>
               <a:rPr lang="en-US" dirty="0"/>
-              <a:t/>
+              <a:t>Open by framing this as a STAT 6395 final project and portfolio proof of concept. The key claim is not simply that I built a Shiny chatbot.</a:t>
+            </a:r>
+            <a:endParaRPr lang="en-US" dirty="0"/>
+          </a:p>
+          <a:p>
+            <a:r>
+              <a:rPr lang="en-US" dirty="0"/>
+              <a:t>The project combines R/Shiny, RAG, an audited practice bank, tutor guardrails, Anthropic/ellmer when configured, visual explanations, and evaluation.</a:t>
+            </a:r>
+            <a:endParaRPr lang="en-US" dirty="0"/>
+          </a:p>
+          <a:p>
+            <a:r>
+              <a:rPr lang="en-US" dirty="0"/>
+              <a:t>Emphasize local proof-of-concept status: the architecture is shareable, but private or copyrighted course assets are not redistributed.</a:t>
             </a:r>
             <a:endParaRPr lang="en-US" dirty="0"/>
           </a:p>
@@ -546,7 +560,7 @@
     </p:spTree>
     <p:extLst>
       <p:ext uri="{BB962C8B-B14F-4D97-AF65-F5344CB8AC3E}">
-        <p14:creationId xmlns:p14="http://schemas.microsoft.com/office/powerpoint/2010/main" val="1024086991"/>
+        <ns2:creationId val="1024086991"/>
       </p:ext>
     </p:extLst>
   </p:cSld>
@@ -557,7 +571,7 @@
 </file>
 
 <file path=ppt/notesSlides/notesSlide10.xml><?xml version="1.0" encoding="utf-8"?>
-<p:notes xmlns:a="http://schemas.openxmlformats.org/drawingml/2006/main" xmlns:r="http://schemas.openxmlformats.org/officeDocument/2006/relationships" xmlns:p="http://schemas.openxmlformats.org/presentationml/2006/main">
+<p:notes xmlns:a="http://schemas.openxmlformats.org/drawingml/2006/main" xmlns:ns2="http://schemas.microsoft.com/office/powerpoint/2010/main" xmlns:p="http://schemas.openxmlformats.org/presentationml/2006/main">
   <p:cSld>
     <p:spTree>
       <p:nvGrpSpPr>
@@ -602,7 +616,21 @@
           <a:p>
             <a:r>
               <a:rPr lang="en-US" dirty="0"/>
-              <a:t/>
+              <a:t>Use this slide to show that the hard parts were product and evaluation issues around the model.</a:t>
+            </a:r>
+            <a:endParaRPr lang="en-US" dirty="0"/>
+          </a:p>
+          <a:p>
+            <a:r>
+              <a:rPr lang="en-US" dirty="0"/>
+              <a:t>Latency came from retrieval, model calls, safety checks, and visual work, so the app avoids LLM calls at practice start and caches context where possible.</a:t>
+            </a:r>
+            <a:endParaRPr lang="en-US" dirty="0"/>
+          </a:p>
+          <a:p>
+            <a:r>
+              <a:rPr lang="en-US" dirty="0"/>
+              <a:t>Visual relevance was a real bug class: the app now prioritizes the student's specific visual request before falling back to current-question context.</a:t>
             </a:r>
             <a:endParaRPr lang="en-US" dirty="0"/>
           </a:p>
@@ -634,7 +662,7 @@
     </p:spTree>
     <p:extLst>
       <p:ext uri="{BB962C8B-B14F-4D97-AF65-F5344CB8AC3E}">
-        <p14:creationId xmlns:p14="http://schemas.microsoft.com/office/powerpoint/2010/main" val="1024086991"/>
+        <ns2:creationId val="1024086991"/>
       </p:ext>
     </p:extLst>
   </p:cSld>
@@ -645,7 +673,7 @@
 </file>
 
 <file path=ppt/notesSlides/notesSlide11.xml><?xml version="1.0" encoding="utf-8"?>
-<p:notes xmlns:a="http://schemas.openxmlformats.org/drawingml/2006/main" xmlns:r="http://schemas.openxmlformats.org/officeDocument/2006/relationships" xmlns:p="http://schemas.openxmlformats.org/presentationml/2006/main">
+<p:notes xmlns:a="http://schemas.openxmlformats.org/drawingml/2006/main" xmlns:ns2="http://schemas.microsoft.com/office/powerpoint/2010/main" xmlns:p="http://schemas.openxmlformats.org/presentationml/2006/main">
   <p:cSld>
     <p:spTree>
       <p:nvGrpSpPr>
@@ -690,7 +718,21 @@
           <a:p>
             <a:r>
               <a:rPr lang="en-US" dirty="0"/>
-              <a:t/>
+              <a:t>Summarize what worked: prebuilt questions, current-question context, RAG/reranking, smoke tests, R-rendered visuals, and guardrails.</a:t>
+            </a:r>
+            <a:endParaRPr lang="en-US" dirty="0"/>
+          </a:p>
+          <a:p>
+            <a:r>
+              <a:rPr lang="en-US" dirty="0"/>
+              <a:t>The most important lesson is that the model is only one component; the surrounding workflow makes it useful for education.</a:t>
+            </a:r>
+            <a:endParaRPr lang="en-US" dirty="0"/>
+          </a:p>
+          <a:p>
+            <a:r>
+              <a:rPr lang="en-US" dirty="0"/>
+              <a:t>Tie this back to course topics: text preprocessing, retrieval, prompt engineering, evaluation, tool use, and deployment tradeoffs.</a:t>
             </a:r>
             <a:endParaRPr lang="en-US" dirty="0"/>
           </a:p>
@@ -722,7 +764,7 @@
     </p:spTree>
     <p:extLst>
       <p:ext uri="{BB962C8B-B14F-4D97-AF65-F5344CB8AC3E}">
-        <p14:creationId xmlns:p14="http://schemas.microsoft.com/office/powerpoint/2010/main" val="1024086991"/>
+        <ns2:creationId val="1024086991"/>
       </p:ext>
     </p:extLst>
   </p:cSld>
@@ -733,7 +775,7 @@
 </file>
 
 <file path=ppt/notesSlides/notesSlide12.xml><?xml version="1.0" encoding="utf-8"?>
-<p:notes xmlns:a="http://schemas.openxmlformats.org/drawingml/2006/main" xmlns:r="http://schemas.openxmlformats.org/officeDocument/2006/relationships" xmlns:p="http://schemas.openxmlformats.org/presentationml/2006/main">
+<p:notes xmlns:a="http://schemas.openxmlformats.org/drawingml/2006/main" xmlns:ns2="http://schemas.microsoft.com/office/powerpoint/2010/main" xmlns:p="http://schemas.openxmlformats.org/presentationml/2006/main">
   <p:cSld>
     <p:spTree>
       <p:nvGrpSpPr>
@@ -778,7 +820,21 @@
           <a:p>
             <a:r>
               <a:rPr lang="en-US" dirty="0"/>
-              <a:t/>
+              <a:t>Be honest about production gaps: hosting, secure API keys, response caching, streaming, monitoring, and more instructor review.</a:t>
+            </a:r>
+            <a:endParaRPr lang="en-US" dirty="0"/>
+          </a:p>
+          <a:p>
+            <a:r>
+              <a:rPr lang="en-US" dirty="0"/>
+              <a:t>On shinyapps.io, bundling .Renviron is only a proof-of-concept demo convenience; production should use managed secrets and stronger privacy/logging policies.</a:t>
+            </a:r>
+            <a:endParaRPr lang="en-US" dirty="0"/>
+          </a:p>
+          <a:p>
+            <a:r>
+              <a:rPr lang="en-US" dirty="0"/>
+              <a:t>For public deployment, textbook and visual permissions matter. Recreated visuals are safer, but source-backed RAG requires permission-cleared materials.</a:t>
             </a:r>
             <a:endParaRPr lang="en-US" dirty="0"/>
           </a:p>
@@ -810,7 +866,7 @@
     </p:spTree>
     <p:extLst>
       <p:ext uri="{BB962C8B-B14F-4D97-AF65-F5344CB8AC3E}">
-        <p14:creationId xmlns:p14="http://schemas.microsoft.com/office/powerpoint/2010/main" val="1024086991"/>
+        <ns2:creationId val="1024086991"/>
       </p:ext>
     </p:extLst>
   </p:cSld>
@@ -821,7 +877,7 @@
 </file>
 
 <file path=ppt/notesSlides/notesSlide13.xml><?xml version="1.0" encoding="utf-8"?>
-<p:notes xmlns:a="http://schemas.openxmlformats.org/drawingml/2006/main" xmlns:r="http://schemas.openxmlformats.org/officeDocument/2006/relationships" xmlns:p="http://schemas.openxmlformats.org/presentationml/2006/main">
+<p:notes xmlns:a="http://schemas.openxmlformats.org/drawingml/2006/main" xmlns:ns2="http://schemas.microsoft.com/office/powerpoint/2010/main" xmlns:p="http://schemas.openxmlformats.org/presentationml/2006/main">
   <p:cSld>
     <p:spTree>
       <p:nvGrpSpPr>
@@ -866,7 +922,21 @@
           <a:p>
             <a:r>
               <a:rPr lang="en-US" dirty="0"/>
-              <a:t/>
+              <a:t>Close with the central takeaway: the value is the guarded workflow, not just a chatbot interface.</a:t>
+            </a:r>
+            <a:endParaRPr lang="en-US" dirty="0"/>
+          </a:p>
+          <a:p>
+            <a:r>
+              <a:rPr lang="en-US" dirty="0"/>
+              <a:t>Mention the reproducibility story: GitHub contains the code, tutorial, audits, public-safe demo corpus, deploy-safe visuals, and setup checks.</a:t>
+            </a:r>
+            <a:endParaRPr lang="en-US" dirty="0"/>
+          </a:p>
+          <a:p>
+            <a:r>
+              <a:rPr lang="en-US" dirty="0"/>
+              <a:t>Restate the source boundary: local permission-cleared materials can support textbook/course RAG, but the public repository avoids redistributing copyrighted or private course content.</a:t>
             </a:r>
             <a:endParaRPr lang="en-US" dirty="0"/>
           </a:p>
@@ -898,7 +968,7 @@
     </p:spTree>
     <p:extLst>
       <p:ext uri="{BB962C8B-B14F-4D97-AF65-F5344CB8AC3E}">
-        <p14:creationId xmlns:p14="http://schemas.microsoft.com/office/powerpoint/2010/main" val="1024086991"/>
+        <ns2:creationId val="1024086991"/>
       </p:ext>
     </p:extLst>
   </p:cSld>
@@ -909,7 +979,7 @@
 </file>
 
 <file path=ppt/notesSlides/notesSlide2.xml><?xml version="1.0" encoding="utf-8"?>
-<p:notes xmlns:a="http://schemas.openxmlformats.org/drawingml/2006/main" xmlns:r="http://schemas.openxmlformats.org/officeDocument/2006/relationships" xmlns:p="http://schemas.openxmlformats.org/presentationml/2006/main">
+<p:notes xmlns:a="http://schemas.openxmlformats.org/drawingml/2006/main" xmlns:ns2="http://schemas.microsoft.com/office/powerpoint/2010/main" xmlns:p="http://schemas.openxmlformats.org/presentationml/2006/main">
   <p:cSld>
     <p:spTree>
       <p:nvGrpSpPr>
@@ -954,7 +1024,21 @@
           <a:p>
             <a:r>
               <a:rPr lang="en-US" dirty="0"/>
-              <a:t/>
+              <a:t>Explain the student pain point: help is most needed while practicing, not after leaving the question.</a:t>
+            </a:r>
+            <a:endParaRPr lang="en-US" dirty="0"/>
+          </a:p>
+          <a:p>
+            <a:r>
+              <a:rPr lang="en-US" dirty="0"/>
+              <a:t>Static practice is fast but cannot adapt. Generic chat is flexible but can hallucinate, drift off-topic, or reveal final answers.</a:t>
+            </a:r>
+            <a:endParaRPr lang="en-US" dirty="0"/>
+          </a:p>
+          <a:p>
+            <a:r>
+              <a:rPr lang="en-US" dirty="0"/>
+              <a:t>The product answer is a controlled practice loop with embedded, grounded help.</a:t>
             </a:r>
             <a:endParaRPr lang="en-US" dirty="0"/>
           </a:p>
@@ -986,7 +1070,7 @@
     </p:spTree>
     <p:extLst>
       <p:ext uri="{BB962C8B-B14F-4D97-AF65-F5344CB8AC3E}">
-        <p14:creationId xmlns:p14="http://schemas.microsoft.com/office/powerpoint/2010/main" val="1024086991"/>
+        <ns2:creationId val="1024086991"/>
       </p:ext>
     </p:extLst>
   </p:cSld>
@@ -997,7 +1081,7 @@
 </file>
 
 <file path=ppt/notesSlides/notesSlide3.xml><?xml version="1.0" encoding="utf-8"?>
-<p:notes xmlns:a="http://schemas.openxmlformats.org/drawingml/2006/main" xmlns:r="http://schemas.openxmlformats.org/officeDocument/2006/relationships" xmlns:p="http://schemas.openxmlformats.org/presentationml/2006/main">
+<p:notes xmlns:a="http://schemas.openxmlformats.org/drawingml/2006/main" xmlns:ns2="http://schemas.microsoft.com/office/powerpoint/2010/main" xmlns:p="http://schemas.openxmlformats.org/presentationml/2006/main">
   <p:cSld>
     <p:spTree>
       <p:nvGrpSpPr>
@@ -1042,7 +1126,21 @@
           <a:p>
             <a:r>
               <a:rPr lang="en-US" dirty="0"/>
-              <a:t/>
+              <a:t>Walk through the product at a high level: choose one or more module cards, answer audited questions, and ask for contextual help.</a:t>
+            </a:r>
+            <a:endParaRPr lang="en-US" dirty="0"/>
+          </a:p>
+          <a:p>
+            <a:r>
+              <a:rPr lang="en-US" dirty="0"/>
+              <a:t>Mention that multi-module selection supports cumulative review while still constraining practice and retrieval to the selected module pool.</a:t>
+            </a:r>
+            <a:endParaRPr lang="en-US" dirty="0"/>
+          </a:p>
+          <a:p>
+            <a:r>
+              <a:rPr lang="en-US" dirty="0"/>
+              <a:t>The tutor quick actions stay simple: hints and concept explanations. Visual help happens through natural follow-up text so the interface does not become crowded.</a:t>
             </a:r>
             <a:endParaRPr lang="en-US" dirty="0"/>
           </a:p>
@@ -1074,7 +1172,7 @@
     </p:spTree>
     <p:extLst>
       <p:ext uri="{BB962C8B-B14F-4D97-AF65-F5344CB8AC3E}">
-        <p14:creationId xmlns:p14="http://schemas.microsoft.com/office/powerpoint/2010/main" val="1024086991"/>
+        <ns2:creationId val="1024086991"/>
       </p:ext>
     </p:extLst>
   </p:cSld>
@@ -1085,7 +1183,7 @@
 </file>
 
 <file path=ppt/notesSlides/notesSlide4.xml><?xml version="1.0" encoding="utf-8"?>
-<p:notes xmlns:a="http://schemas.openxmlformats.org/drawingml/2006/main" xmlns:r="http://schemas.openxmlformats.org/officeDocument/2006/relationships" xmlns:p="http://schemas.openxmlformats.org/presentationml/2006/main">
+<p:notes xmlns:a="http://schemas.openxmlformats.org/drawingml/2006/main" xmlns:ns2="http://schemas.microsoft.com/office/powerpoint/2010/main" xmlns:p="http://schemas.openxmlformats.org/presentationml/2006/main">
   <p:cSld>
     <p:spTree>
       <p:nvGrpSpPr>
@@ -1130,7 +1228,21 @@
           <a:p>
             <a:r>
               <a:rPr lang="en-US" dirty="0"/>
-              <a:t/>
+              <a:t>Use this slide to separate the deterministic practice loop from the AI support layer.</a:t>
+            </a:r>
+            <a:endParaRPr lang="en-US" dirty="0"/>
+          </a:p>
+          <a:p>
+            <a:r>
+              <a:rPr lang="en-US" dirty="0"/>
+              <a:t>Starting practice should be fast: it samples from a stored question bank, not from an LLM, and it does not rebuild retrieval assets.</a:t>
+            </a:r>
+            <a:endParaRPr lang="en-US" dirty="0"/>
+          </a:p>
+          <a:p>
+            <a:r>
+              <a:rPr lang="en-US" dirty="0"/>
+              <a:t>The tutor enters when the student asks for a hint, explanation, visual, or follow-up. That makes the app easier to control and evaluate.</a:t>
             </a:r>
             <a:endParaRPr lang="en-US" dirty="0"/>
           </a:p>
@@ -1162,7 +1274,7 @@
     </p:spTree>
     <p:extLst>
       <p:ext uri="{BB962C8B-B14F-4D97-AF65-F5344CB8AC3E}">
-        <p14:creationId xmlns:p14="http://schemas.microsoft.com/office/powerpoint/2010/main" val="1024086991"/>
+        <ns2:creationId val="1024086991"/>
       </p:ext>
     </p:extLst>
   </p:cSld>
@@ -1173,7 +1285,7 @@
 </file>
 
 <file path=ppt/notesSlides/notesSlide5.xml><?xml version="1.0" encoding="utf-8"?>
-<p:notes xmlns:a="http://schemas.openxmlformats.org/drawingml/2006/main" xmlns:r="http://schemas.openxmlformats.org/officeDocument/2006/relationships" xmlns:p="http://schemas.openxmlformats.org/presentationml/2006/main">
+<p:notes xmlns:a="http://schemas.openxmlformats.org/drawingml/2006/main" xmlns:ns2="http://schemas.microsoft.com/office/powerpoint/2010/main" xmlns:p="http://schemas.openxmlformats.org/presentationml/2006/main">
   <p:cSld>
     <p:spTree>
       <p:nvGrpSpPr>
@@ -1218,7 +1330,21 @@
           <a:p>
             <a:r>
               <a:rPr lang="en-US" dirty="0"/>
-              <a:t/>
+              <a:t>Stress the design choice: the LLM is selective. Routine work stays local and reproducible.</a:t>
+            </a:r>
+            <a:endParaRPr lang="en-US" dirty="0"/>
+          </a:p>
+          <a:p>
+            <a:r>
+              <a:rPr lang="en-US" dirty="0"/>
+              <a:t>Stored hints, answer checking, question selection, and R-rendered visuals avoid unnecessary model calls. Anthropic is used when configured for richer explanations and follow-ups.</a:t>
+            </a:r>
+            <a:endParaRPr lang="en-US" dirty="0"/>
+          </a:p>
+          <a:p>
+            <a:r>
+              <a:rPr lang="en-US" dirty="0"/>
+              <a:t>For visual help, the app renders the visual with R/ggplot or deploy-safe metadata; the LLM explains the selected visual rather than generating the image.</a:t>
             </a:r>
             <a:endParaRPr lang="en-US" dirty="0"/>
           </a:p>
@@ -1250,7 +1376,7 @@
     </p:spTree>
     <p:extLst>
       <p:ext uri="{BB962C8B-B14F-4D97-AF65-F5344CB8AC3E}">
-        <p14:creationId xmlns:p14="http://schemas.microsoft.com/office/powerpoint/2010/main" val="1024086991"/>
+        <ns2:creationId val="1024086991"/>
       </p:ext>
     </p:extLst>
   </p:cSld>
@@ -1261,7 +1387,7 @@
 </file>
 
 <file path=ppt/notesSlides/notesSlide6.xml><?xml version="1.0" encoding="utf-8"?>
-<p:notes xmlns:a="http://schemas.openxmlformats.org/drawingml/2006/main" xmlns:r="http://schemas.openxmlformats.org/officeDocument/2006/relationships" xmlns:p="http://schemas.openxmlformats.org/presentationml/2006/main">
+<p:notes xmlns:a="http://schemas.openxmlformats.org/drawingml/2006/main" xmlns:ns2="http://schemas.microsoft.com/office/powerpoint/2010/main" xmlns:p="http://schemas.openxmlformats.org/presentationml/2006/main">
   <p:cSld>
     <p:spTree>
       <p:nvGrpSpPr>
@@ -1306,7 +1432,21 @@
           <a:p>
             <a:r>
               <a:rPr lang="en-US" dirty="0"/>
-              <a:t/>
+              <a:t>Explain the RAG chain: the student request plus current question context becomes a normalized query, then retrieval and reranking choose evidence.</a:t>
+            </a:r>
+            <a:endParaRPr lang="en-US" dirty="0"/>
+          </a:p>
+          <a:p>
+            <a:r>
+              <a:rPr lang="en-US" dirty="0"/>
+              <a:t>Important nuance: local professor slides and notes can function as optional overlays in the RAG infrastructure, but the public repo does not include source-derived private artifacts.</a:t>
+            </a:r>
+            <a:endParaRPr lang="en-US" dirty="0"/>
+          </a:p>
+          <a:p>
+            <a:r>
+              <a:rPr lang="en-US" dirty="0"/>
+              <a:t>The tracked question bank is textbook-aligned and audited. Professor/course materials may have informed local evidence and concept consolidation, but they are not redistributed.</a:t>
             </a:r>
             <a:endParaRPr lang="en-US" dirty="0"/>
           </a:p>
@@ -1338,7 +1478,7 @@
     </p:spTree>
     <p:extLst>
       <p:ext uri="{BB962C8B-B14F-4D97-AF65-F5344CB8AC3E}">
-        <p14:creationId xmlns:p14="http://schemas.microsoft.com/office/powerpoint/2010/main" val="1024086991"/>
+        <ns2:creationId val="1024086991"/>
       </p:ext>
     </p:extLst>
   </p:cSld>
@@ -1349,7 +1489,7 @@
 </file>
 
 <file path=ppt/notesSlides/notesSlide7.xml><?xml version="1.0" encoding="utf-8"?>
-<p:notes xmlns:a="http://schemas.openxmlformats.org/drawingml/2006/main" xmlns:r="http://schemas.openxmlformats.org/officeDocument/2006/relationships" xmlns:p="http://schemas.openxmlformats.org/presentationml/2006/main">
+<p:notes xmlns:a="http://schemas.openxmlformats.org/drawingml/2006/main" xmlns:ns2="http://schemas.microsoft.com/office/powerpoint/2010/main" xmlns:p="http://schemas.openxmlformats.org/presentationml/2006/main">
   <p:cSld>
     <p:spTree>
       <p:nvGrpSpPr>
@@ -1394,7 +1534,21 @@
           <a:p>
             <a:r>
               <a:rPr lang="en-US" dirty="0"/>
-              <a:t/>
+              <a:t>Frame this as the tutoring safety problem: helpful support without turning the app into an answer key.</a:t>
+            </a:r>
+            <a:endParaRPr lang="en-US" dirty="0"/>
+          </a:p>
+          <a:p>
+            <a:r>
+              <a:rPr lang="en-US" dirty="0"/>
+              <a:t>Hints should not diagnose an answer before submission, and early help should nudge rather than reveal. Stored hints are used first when they are specific enough.</a:t>
+            </a:r>
+            <a:endParaRPr lang="en-US" dirty="0"/>
+          </a:p>
+          <a:p>
+            <a:r>
+              <a:rPr lang="en-US" dirty="0"/>
+              <a:t>Generated responses are cleaned for student-facing language, checked for answer leakage, and kept tied to the current question concept.</a:t>
             </a:r>
             <a:endParaRPr lang="en-US" dirty="0"/>
           </a:p>
@@ -1426,7 +1580,7 @@
     </p:spTree>
     <p:extLst>
       <p:ext uri="{BB962C8B-B14F-4D97-AF65-F5344CB8AC3E}">
-        <p14:creationId xmlns:p14="http://schemas.microsoft.com/office/powerpoint/2010/main" val="1024086991"/>
+        <ns2:creationId val="1024086991"/>
       </p:ext>
     </p:extLst>
   </p:cSld>
@@ -1437,7 +1591,7 @@
 </file>
 
 <file path=ppt/notesSlides/notesSlide8.xml><?xml version="1.0" encoding="utf-8"?>
-<p:notes xmlns:a="http://schemas.openxmlformats.org/drawingml/2006/main" xmlns:r="http://schemas.openxmlformats.org/officeDocument/2006/relationships" xmlns:p="http://schemas.openxmlformats.org/presentationml/2006/main">
+<p:notes xmlns:a="http://schemas.openxmlformats.org/drawingml/2006/main" xmlns:ns2="http://schemas.microsoft.com/office/powerpoint/2010/main" xmlns:p="http://schemas.openxmlformats.org/presentationml/2006/main">
   <p:cSld>
     <p:spTree>
       <p:nvGrpSpPr>
@@ -1482,7 +1636,21 @@
           <a:p>
             <a:r>
               <a:rPr lang="en-US" dirty="0"/>
-              <a:t/>
+              <a:t>Explain that content quality became a major engineering task, not an afterthought.</a:t>
+            </a:r>
+            <a:endParaRPr lang="en-US" dirty="0"/>
+          </a:p>
+          <a:p>
+            <a:r>
+              <a:rPr lang="en-US" dirty="0"/>
+              <a:t>The current bank has 450 questions and audit outputs for answer choices, metadata, explanations, visuals, and smoke tests.</a:t>
+            </a:r>
+            <a:endParaRPr lang="en-US" dirty="0"/>
+          </a:p>
+          <a:p>
+            <a:r>
+              <a:rPr lang="en-US" dirty="0"/>
+              <a:t>Make the source boundary explicit: the public repo includes deploy-safe demo assets and an audited bank; private textbook or professor-source artifacts stay local and ignored.</a:t>
             </a:r>
             <a:endParaRPr lang="en-US" dirty="0"/>
           </a:p>
@@ -1514,7 +1682,7 @@
     </p:spTree>
     <p:extLst>
       <p:ext uri="{BB962C8B-B14F-4D97-AF65-F5344CB8AC3E}">
-        <p14:creationId xmlns:p14="http://schemas.microsoft.com/office/powerpoint/2010/main" val="1024086991"/>
+        <ns2:creationId val="1024086991"/>
       </p:ext>
     </p:extLst>
   </p:cSld>
@@ -1525,7 +1693,7 @@
 </file>
 
 <file path=ppt/notesSlides/notesSlide9.xml><?xml version="1.0" encoding="utf-8"?>
-<p:notes xmlns:a="http://schemas.openxmlformats.org/drawingml/2006/main" xmlns:r="http://schemas.openxmlformats.org/officeDocument/2006/relationships" xmlns:p="http://schemas.openxmlformats.org/presentationml/2006/main">
+<p:notes xmlns:a="http://schemas.openxmlformats.org/drawingml/2006/main" xmlns:ns2="http://schemas.microsoft.com/office/powerpoint/2010/main" xmlns:p="http://schemas.openxmlformats.org/presentationml/2006/main">
   <p:cSld>
     <p:spTree>
       <p:nvGrpSpPr>
@@ -1570,7 +1738,21 @@
           <a:p>
             <a:r>
               <a:rPr lang="en-US" dirty="0"/>
-              <a:t/>
+              <a:t>This is the planned live demo path. Keep the demo simple: choose module cards, start practice, submit, then ask for help.</a:t>
+            </a:r>
+            <a:endParaRPr lang="en-US" dirty="0"/>
+          </a:p>
+          <a:p>
+            <a:r>
+              <a:rPr lang="en-US" dirty="0"/>
+              <a:t>Point out that no login or role switching appears because this is a cold-start proof-of-concept practice app.</a:t>
+            </a:r>
+            <a:endParaRPr lang="en-US" dirty="0"/>
+          </a:p>
+          <a:p>
+            <a:r>
+              <a:rPr lang="en-US" dirty="0"/>
+              <a:t>For visual support, ask a specific prompt such as "what does a time plot look like?" to show that explicit student requests now take priority over broad context.</a:t>
             </a:r>
             <a:endParaRPr lang="en-US" dirty="0"/>
           </a:p>
@@ -1602,7 +1784,7 @@
     </p:spTree>
     <p:extLst>
       <p:ext uri="{BB962C8B-B14F-4D97-AF65-F5344CB8AC3E}">
-        <p14:creationId xmlns:p14="http://schemas.microsoft.com/office/powerpoint/2010/main" val="1024086991"/>
+        <ns2:creationId val="1024086991"/>
       </p:ext>
     </p:extLst>
   </p:cSld>
@@ -2693,7 +2875,7 @@
                   <a:srgbClr val="64748B"/>
                 </a:solidFill>
               </a:rPr>
-              <a:t>Visuals helped, but only when matched carefully to the current concept.</a:t>
+              <a:t>Visuals helped only when the student request and current concept were both considered.</a:t>
             </a:r>
             <a:endParaRPr lang="en-US" sz="1340" dirty="0"/>
           </a:p>
@@ -3470,7 +3652,7 @@
                   <a:srgbClr val="243B63"/>
                 </a:solidFill>
               </a:rPr>
-              <a:t>Deterministic visuals</a:t>
+              <a:t>R-rendered visuals</a:t>
             </a:r>
             <a:endParaRPr lang="en-US" sz="1440" dirty="0"/>
           </a:p>
@@ -3506,7 +3688,7 @@
                   <a:srgbClr val="1E293B"/>
                 </a:solidFill>
               </a:rPr>
-              <a:t>made explanations reproducible and safer to publish</a:t>
+              <a:t>kept explanations visual, relevant, and deploy-safe</a:t>
             </a:r>
             <a:endParaRPr lang="en-US" sz="1440" dirty="0"/>
           </a:p>
@@ -4970,7 +5152,7 @@
                   <a:srgbClr val="243B63"/>
                 </a:solidFill>
               </a:rPr>
-              <a:t>This project shows how LLMs can add value to a statistics learning workflow when they are grounded, constrained, and paired with traditional engineering tools: an audited question bank, deterministic visuals, automated tests, and reproducible setup.</a:t>
+              <a:t>This project shows how LLMs can add value to a statistics learning workflow when they are grounded, constrained, and paired with traditional engineering tools: an audited question bank, R-rendered visuals, automated tests, and reproducible setup.</a:t>
             </a:r>
             <a:endParaRPr lang="en-US" sz="2100" dirty="0"/>
           </a:p>
@@ -6536,7 +6718,7 @@
                   <a:srgbClr val="1E293B"/>
                 </a:solidFill>
               </a:rPr>
-              <a:t>Students choose a topic area or cumulative review before starting.</a:t>
+              <a:t>Students choose one or more modules, including cumulative review.</a:t>
             </a:r>
             <a:endParaRPr lang="en-US" sz="1400" dirty="0"/>
           </a:p>
@@ -6810,7 +6992,7 @@
                   <a:srgbClr val="1E293B"/>
                 </a:solidFill>
               </a:rPr>
-              <a:t>Students can ask for a hint or a concept explanation while practicing.</a:t>
+              <a:t>Students can ask for hints, concept explanations, or visual follow-ups while practicing.</a:t>
             </a:r>
             <a:endParaRPr lang="en-US" sz="1400" dirty="0"/>
           </a:p>
@@ -7319,7 +7501,7 @@
                 <a:ea typeface="Calibri" pitchFamily="34" charset="-122"/>
                 <a:cs typeface="Calibri" pitchFamily="34" charset="-120"/>
               </a:rPr>
-              <a:t>module</a:t>
+              <a:t>module(s)</a:t>
             </a:r>
             <a:endParaRPr lang="en-US" sz="1250" dirty="0"/>
           </a:p>
@@ -8789,7 +8971,7 @@
                 <a:ea typeface="Calibri" pitchFamily="34" charset="-122"/>
                 <a:cs typeface="Calibri" pitchFamily="34" charset="-120"/>
               </a:rPr>
-              <a:t>ggplot-based visuals</a:t>
+              <a:t>R-rendered visuals</a:t>
             </a:r>
             <a:endParaRPr lang="en-US" sz="1520" dirty="0"/>
           </a:p>
@@ -9045,7 +9227,7 @@
                 <a:ea typeface="Calibri" pitchFamily="34" charset="-122"/>
                 <a:cs typeface="Calibri" pitchFamily="34" charset="-120"/>
               </a:rPr>
-              <a:t>grounded tutor responses</a:t>
+              <a:t>grounded tutor and visual explanations</a:t>
             </a:r>
             <a:endParaRPr lang="en-US" sz="1520" dirty="0"/>
           </a:p>
@@ -9503,7 +9685,7 @@
                   <a:srgbClr val="64748B"/>
                 </a:solidFill>
               </a:rPr>
-              <a:t>hint, concept help, or follow-up</a:t>
+              <a:t>hint, concept, visual, or follow-up</a:t>
             </a:r>
             <a:endParaRPr lang="en-US" sz="1250" dirty="0"/>
           </a:p>
@@ -9911,7 +10093,7 @@
                   <a:srgbClr val="64748B"/>
                 </a:solidFill>
               </a:rPr>
-              <a:t>prefer concept and module matches</a:t>
+              <a:t>module/concept match; textbook first</a:t>
             </a:r>
             <a:endParaRPr lang="en-US" sz="1250" dirty="0"/>
           </a:p>
@@ -10155,7 +10337,7 @@
                   <a:srgbClr val="1E293B"/>
                 </a:solidFill>
               </a:rPr>
-              <a:t>Uses retrieved course context, not the model’s memory.</a:t>
+              <a:t>Uses textbook-first evidence, not model memory.</a:t>
             </a:r>
             <a:endParaRPr lang="en-US" sz="1420" dirty="0"/>
           </a:p>
@@ -10193,7 +10375,7 @@
                   <a:srgbClr val="1E293B"/>
                 </a:solidFill>
               </a:rPr>
-              <a:t>This keeps responses more relevant to the selected module.</a:t>
+              <a:t>Local course materials stay as optional overlays; public repo keeps them out.</a:t>
             </a:r>
             <a:endParaRPr lang="en-US" sz="1420" dirty="0"/>
           </a:p>
@@ -10805,7 +10987,7 @@
                 <a:ea typeface="Calibri" pitchFamily="34" charset="-122"/>
                 <a:cs typeface="Calibri" pitchFamily="34" charset="-120"/>
               </a:rPr>
-              <a:t>LLM draft</a:t>
+              <a:t>Draft or stored hint</a:t>
             </a:r>
             <a:endParaRPr lang="en-US" sz="1250" dirty="0"/>
           </a:p>
@@ -10972,7 +11154,7 @@
                 <a:ea typeface="Calibri" pitchFamily="34" charset="-122"/>
                 <a:cs typeface="Calibri" pitchFamily="34" charset="-120"/>
               </a:rPr>
-              <a:t>Faithfulness</a:t>
+              <a:t>Faithfulness when needed</a:t>
             </a:r>
             <a:endParaRPr lang="en-US" sz="1250" dirty="0"/>
           </a:p>
@@ -11767,7 +11949,7 @@
                 <a:ea typeface="Calibri" pitchFamily="34" charset="-122"/>
                 <a:cs typeface="Calibri" pitchFamily="34" charset="-120"/>
               </a:rPr>
-              <a:t>• </a:t>
+              <a:t>- </a:t>
             </a:r>
             <a:pPr indent="0" marL="0">
               <a:buNone/>
@@ -11822,7 +12004,7 @@
                 <a:ea typeface="Calibri" pitchFamily="34" charset="-122"/>
                 <a:cs typeface="Calibri" pitchFamily="34" charset="-120"/>
               </a:rPr>
-              <a:t>• </a:t>
+              <a:t>- </a:t>
             </a:r>
             <a:pPr indent="0" marL="0">
               <a:buNone/>
@@ -11877,7 +12059,7 @@
                 <a:ea typeface="Calibri" pitchFamily="34" charset="-122"/>
                 <a:cs typeface="Calibri" pitchFamily="34" charset="-120"/>
               </a:rPr>
-              <a:t>• </a:t>
+              <a:t>- </a:t>
             </a:r>
             <a:pPr indent="0" marL="0">
               <a:buNone/>
@@ -11932,7 +12114,7 @@
                 <a:ea typeface="Calibri" pitchFamily="34" charset="-122"/>
                 <a:cs typeface="Calibri" pitchFamily="34" charset="-120"/>
               </a:rPr>
-              <a:t>• </a:t>
+              <a:t>- </a:t>
             </a:r>
             <a:pPr indent="0" marL="0">
               <a:buNone/>
@@ -11987,7 +12169,7 @@
                 <a:ea typeface="Calibri" pitchFamily="34" charset="-122"/>
                 <a:cs typeface="Calibri" pitchFamily="34" charset="-120"/>
               </a:rPr>
-              <a:t>• </a:t>
+              <a:t>- </a:t>
             </a:r>
             <a:pPr indent="0" marL="0">
               <a:buNone/>
@@ -12037,7 +12219,7 @@
                   <a:srgbClr val="243B63"/>
                 </a:solidFill>
               </a:rPr>
-              <a:t>Visual strategy</a:t>
+              <a:t>Visual + reproducibility strategy</a:t>
             </a:r>
             <a:endParaRPr lang="en-US" sz="1800" dirty="0"/>
           </a:p>
@@ -12078,7 +12260,7 @@
                 <a:ea typeface="Calibri" pitchFamily="34" charset="-122"/>
                 <a:cs typeface="Calibri" pitchFamily="34" charset="-120"/>
               </a:rPr>
-              <a:t>• </a:t>
+              <a:t>- </a:t>
             </a:r>
             <a:pPr indent="0" marL="0">
               <a:buNone/>
@@ -12133,7 +12315,7 @@
                 <a:ea typeface="Calibri" pitchFamily="34" charset="-122"/>
                 <a:cs typeface="Calibri" pitchFamily="34" charset="-120"/>
               </a:rPr>
-              <a:t>• </a:t>
+              <a:t>- </a:t>
             </a:r>
             <a:pPr indent="0" marL="0">
               <a:buNone/>
@@ -12188,7 +12370,7 @@
                 <a:ea typeface="Calibri" pitchFamily="34" charset="-122"/>
                 <a:cs typeface="Calibri" pitchFamily="34" charset="-120"/>
               </a:rPr>
-              <a:t>• </a:t>
+              <a:t>- </a:t>
             </a:r>
             <a:pPr indent="0" marL="0">
               <a:buNone/>
@@ -12243,7 +12425,7 @@
                 <a:ea typeface="Calibri" pitchFamily="34" charset="-122"/>
                 <a:cs typeface="Calibri" pitchFamily="34" charset="-120"/>
               </a:rPr>
-              <a:t>• </a:t>
+              <a:t>- </a:t>
             </a:r>
             <a:pPr indent="0" marL="0">
               <a:buNone/>
@@ -12257,7 +12439,7 @@
                 <a:ea typeface="Calibri" pitchFamily="34" charset="-122"/>
                 <a:cs typeface="Calibri" pitchFamily="34" charset="-120"/>
               </a:rPr>
-              <a:t>treat visuals as support, not decoration</a:t>
+              <a:t>include renv, CI, and public-safe demo corpus</a:t>
             </a:r>
             <a:endParaRPr lang="en-US" sz="1380" dirty="0"/>
           </a:p>
@@ -12702,7 +12884,7 @@
                   <a:srgbClr val="243B63"/>
                 </a:solidFill>
               </a:rPr>
-              <a:t>Choose module</a:t>
+              <a:t>Choose module cards</a:t>
             </a:r>
             <a:endParaRPr lang="en-US" sz="1750" dirty="0"/>
           </a:p>
@@ -12738,7 +12920,7 @@
                   <a:srgbClr val="64748B"/>
                 </a:solidFill>
               </a:rPr>
-              <a:t>or cumulative review</a:t>
+              <a:t>one or more modules</a:t>
             </a:r>
             <a:endParaRPr lang="en-US" sz="1280" dirty="0"/>
           </a:p>
@@ -13004,7 +13186,7 @@
                   <a:srgbClr val="64748B"/>
                 </a:solidFill>
               </a:rPr>
-              <a:t>hint or concept explanation</a:t>
+              <a:t>hint, concept, or visual follow-up</a:t>
             </a:r>
             <a:endParaRPr lang="en-US" sz="1280" dirty="0"/>
           </a:p>
@@ -13333,7 +13515,7 @@
                   <a:srgbClr val="FFFFFF"/>
                 </a:solidFill>
               </a:rPr>
-              <a:t>If the API is slow, I will use screenshots as backup — but the intended demo is live.</a:t>
+              <a:t>If the API is slow, I will use screenshots as backup â€” but the intended demo is live.</a:t>
             </a:r>
             <a:endParaRPr lang="en-US" sz="1420" dirty="0"/>
           </a:p>

</xml_diff>